<commit_message>
Fix plots not updating in weather briefing
Template plots did not have the right name, so script could not find them to replace them with the actual plots.
</commit_message>
<xml_diff>
--- a/WeatherbriefingKenya_template2.pptx
+++ b/WeatherbriefingKenya_template2.pptx
@@ -207,7 +207,7 @@
           <a:p>
             <a:fld id="{A43131C5-BDE0-4ACE-9C34-EFE9D196AAB1}" type="datetimeFigureOut">
               <a:rPr lang="en-US" smtClean="0"/>
-              <a:t>8/4/2026</a:t>
+              <a:t>8/6/2026</a:t>
             </a:fld>
             <a:endParaRPr lang="en-US"/>
           </a:p>
@@ -873,7 +873,7 @@
           <a:p>
             <a:fld id="{EB5E7B66-BBF3-4C82-9864-576602C32F66}" type="datetimeFigureOut">
               <a:rPr lang="en-US" smtClean="0"/>
-              <a:t>8/4/2026</a:t>
+              <a:t>8/6/2026</a:t>
             </a:fld>
             <a:endParaRPr lang="en-US"/>
           </a:p>
@@ -1071,7 +1071,7 @@
           <a:p>
             <a:fld id="{EB5E7B66-BBF3-4C82-9864-576602C32F66}" type="datetimeFigureOut">
               <a:rPr lang="en-US" smtClean="0"/>
-              <a:t>8/4/2026</a:t>
+              <a:t>8/6/2026</a:t>
             </a:fld>
             <a:endParaRPr lang="en-US"/>
           </a:p>
@@ -1279,7 +1279,7 @@
           <a:p>
             <a:fld id="{EB5E7B66-BBF3-4C82-9864-576602C32F66}" type="datetimeFigureOut">
               <a:rPr lang="en-US" smtClean="0"/>
-              <a:t>8/4/2026</a:t>
+              <a:t>8/6/2026</a:t>
             </a:fld>
             <a:endParaRPr lang="en-US"/>
           </a:p>
@@ -1477,7 +1477,7 @@
           <a:p>
             <a:fld id="{EB5E7B66-BBF3-4C82-9864-576602C32F66}" type="datetimeFigureOut">
               <a:rPr lang="en-US" smtClean="0"/>
-              <a:t>8/4/2026</a:t>
+              <a:t>8/6/2026</a:t>
             </a:fld>
             <a:endParaRPr lang="en-US"/>
           </a:p>
@@ -1752,7 +1752,7 @@
           <a:p>
             <a:fld id="{EB5E7B66-BBF3-4C82-9864-576602C32F66}" type="datetimeFigureOut">
               <a:rPr lang="en-US" smtClean="0"/>
-              <a:t>8/4/2026</a:t>
+              <a:t>8/6/2026</a:t>
             </a:fld>
             <a:endParaRPr lang="en-US"/>
           </a:p>
@@ -2017,7 +2017,7 @@
           <a:p>
             <a:fld id="{EB5E7B66-BBF3-4C82-9864-576602C32F66}" type="datetimeFigureOut">
               <a:rPr lang="en-US" smtClean="0"/>
-              <a:t>8/4/2026</a:t>
+              <a:t>8/6/2026</a:t>
             </a:fld>
             <a:endParaRPr lang="en-US"/>
           </a:p>
@@ -2429,7 +2429,7 @@
           <a:p>
             <a:fld id="{EB5E7B66-BBF3-4C82-9864-576602C32F66}" type="datetimeFigureOut">
               <a:rPr lang="en-US" smtClean="0"/>
-              <a:t>8/4/2026</a:t>
+              <a:t>8/6/2026</a:t>
             </a:fld>
             <a:endParaRPr lang="en-US"/>
           </a:p>
@@ -2570,7 +2570,7 @@
           <a:p>
             <a:fld id="{EB5E7B66-BBF3-4C82-9864-576602C32F66}" type="datetimeFigureOut">
               <a:rPr lang="en-US" smtClean="0"/>
-              <a:t>8/4/2026</a:t>
+              <a:t>8/6/2026</a:t>
             </a:fld>
             <a:endParaRPr lang="en-US"/>
           </a:p>
@@ -2683,7 +2683,7 @@
           <a:p>
             <a:fld id="{EB5E7B66-BBF3-4C82-9864-576602C32F66}" type="datetimeFigureOut">
               <a:rPr lang="en-US" smtClean="0"/>
-              <a:t>8/4/2026</a:t>
+              <a:t>8/6/2026</a:t>
             </a:fld>
             <a:endParaRPr lang="en-US"/>
           </a:p>
@@ -2994,7 +2994,7 @@
           <a:p>
             <a:fld id="{EB5E7B66-BBF3-4C82-9864-576602C32F66}" type="datetimeFigureOut">
               <a:rPr lang="en-US" smtClean="0"/>
-              <a:t>8/4/2026</a:t>
+              <a:t>8/6/2026</a:t>
             </a:fld>
             <a:endParaRPr lang="en-US"/>
           </a:p>
@@ -3282,7 +3282,7 @@
           <a:p>
             <a:fld id="{EB5E7B66-BBF3-4C82-9864-576602C32F66}" type="datetimeFigureOut">
               <a:rPr lang="en-US" smtClean="0"/>
-              <a:t>8/4/2026</a:t>
+              <a:t>8/6/2026</a:t>
             </a:fld>
             <a:endParaRPr lang="en-US"/>
           </a:p>
@@ -3523,7 +3523,7 @@
           <a:p>
             <a:fld id="{EB5E7B66-BBF3-4C82-9864-576602C32F66}" type="datetimeFigureOut">
               <a:rPr lang="en-US" smtClean="0"/>
-              <a:t>8/4/2026</a:t>
+              <a:t>8/6/2026</a:t>
             </a:fld>
             <a:endParaRPr lang="en-US"/>
           </a:p>
@@ -4296,7 +4296,7 @@
       </p:sp>
       <p:pic>
         <p:nvPicPr>
-          <p:cNvPr id="5" name="Picture 4">
+          <p:cNvPr id="5" name="Picture 7">
             <a:extLst>
               <a:ext uri="{FF2B5EF4-FFF2-40B4-BE49-F238E27FC236}">
                 <a16:creationId xmlns:a16="http://schemas.microsoft.com/office/drawing/2014/main" id="{2ED61167-07F6-26EE-FEE0-8032C7206B98}"/>
@@ -4747,7 +4747,7 @@
       </p:sp>
       <p:pic>
         <p:nvPicPr>
-          <p:cNvPr id="7" name="Picture 6" descr="weekly_precip.png"/>
+          <p:cNvPr id="7" name="ECMWF_raw_plot" descr="weekly_precip.png"/>
           <p:cNvPicPr>
             <a:picLocks noChangeAspect="1"/>
           </p:cNvPicPr>
@@ -4872,7 +4872,7 @@
       </p:sp>
       <p:pic>
         <p:nvPicPr>
-          <p:cNvPr id="7" name="Picture 6" descr="gefs_weekly_precip.png"/>
+          <p:cNvPr id="7" name="GEFS_raw_plot" descr="gefs_weekly_precip.png"/>
           <p:cNvPicPr>
             <a:picLocks noChangeAspect="1"/>
           </p:cNvPicPr>
@@ -4997,7 +4997,7 @@
       </p:sp>
       <p:pic>
         <p:nvPicPr>
-          <p:cNvPr id="7" name="Picture 6" descr="weekly_precip_downscaled.png"/>
+          <p:cNvPr id="7" name="ECMWF_dwn_plot" descr="weekly_precip_downscaled.png"/>
           <p:cNvPicPr>
             <a:picLocks noChangeAspect="1"/>
           </p:cNvPicPr>
@@ -5123,7 +5123,7 @@
       </p:sp>
       <p:pic>
         <p:nvPicPr>
-          <p:cNvPr id="7" name="Picture 6" descr="weekly_medium_range_precip.png"/>
+          <p:cNvPr id="7" name="ECMWFmed_raw_plot" descr="weekly_medium_range_precip.png"/>
           <p:cNvPicPr>
             <a:picLocks noChangeAspect="1"/>
           </p:cNvPicPr>
@@ -5249,7 +5249,7 @@
       </p:sp>
       <p:pic>
         <p:nvPicPr>
-          <p:cNvPr id="7" name="Picture 6" descr="chance_of_above_or_below.png"/>
+          <p:cNvPr id="7" name="ECMWF_tercile_plot" descr="chance_of_above_or_below.png"/>
           <p:cNvPicPr>
             <a:picLocks noChangeAspect="1"/>
           </p:cNvPicPr>
@@ -5375,7 +5375,7 @@
       </p:sp>
       <p:pic>
         <p:nvPicPr>
-          <p:cNvPr id="7" name="Picture 6" descr="efi_sot_precip.png"/>
+          <p:cNvPr id="7" name="ECMWF_efi_plot" descr="efi_sot_precip.png"/>
           <p:cNvPicPr>
             <a:picLocks noChangeAspect="1"/>
           </p:cNvPicPr>
@@ -5501,7 +5501,7 @@
       </p:sp>
       <p:pic>
         <p:nvPicPr>
-          <p:cNvPr id="7" name="Picture 6" descr="50th_percentile_exedance.png"/>
+          <p:cNvPr id="7" name="ECMWF_p50_plot" descr="50th_percentile_exedance.png"/>
           <p:cNvPicPr>
             <a:picLocks noChangeAspect="1"/>
           </p:cNvPicPr>
@@ -5629,7 +5629,7 @@
       </p:sp>
       <p:pic>
         <p:nvPicPr>
-          <p:cNvPr id="7" name="Picture 6" descr="anomaly_from_50th.png"/>
+          <p:cNvPr id="7" name="ECMWF_p50anom_plot" descr="anomaly_from_50th.png"/>
           <p:cNvPicPr>
             <a:picLocks noChangeAspect="1"/>
           </p:cNvPicPr>

</xml_diff>

<commit_message>
add IOD diagnostic plot
</commit_message>
<xml_diff>
--- a/WeatherbriefingKenya_template2.pptx
+++ b/WeatherbriefingKenya_template2.pptx
@@ -5,7 +5,7 @@
     <p:sldMasterId id="2147483648" r:id="rId1"/>
   </p:sldMasterIdLst>
   <p:notesMasterIdLst>
-    <p:notesMasterId r:id="rId13"/>
+    <p:notesMasterId r:id="rId14"/>
   </p:notesMasterIdLst>
   <p:sldIdLst>
     <p:sldId id="256" r:id="rId2"/>
@@ -19,6 +19,7 @@
     <p:sldId id="278" r:id="rId10"/>
     <p:sldId id="283" r:id="rId11"/>
     <p:sldId id="271" r:id="rId12"/>
+    <p:sldId id="285" r:id="rId13"/>
   </p:sldIdLst>
   <p:sldSz cx="12192000" cy="6858000"/>
   <p:notesSz cx="6858000" cy="9144000"/>
@@ -207,7 +208,7 @@
           <a:p>
             <a:fld id="{A43131C5-BDE0-4ACE-9C34-EFE9D196AAB1}" type="datetimeFigureOut">
               <a:rPr lang="en-US" smtClean="0"/>
-              <a:t>8/6/2026</a:t>
+              <a:t>8/14/2026</a:t>
             </a:fld>
             <a:endParaRPr lang="en-US"/>
           </a:p>
@@ -873,7 +874,7 @@
           <a:p>
             <a:fld id="{EB5E7B66-BBF3-4C82-9864-576602C32F66}" type="datetimeFigureOut">
               <a:rPr lang="en-US" smtClean="0"/>
-              <a:t>8/6/2026</a:t>
+              <a:t>8/14/2026</a:t>
             </a:fld>
             <a:endParaRPr lang="en-US"/>
           </a:p>
@@ -1071,7 +1072,7 @@
           <a:p>
             <a:fld id="{EB5E7B66-BBF3-4C82-9864-576602C32F66}" type="datetimeFigureOut">
               <a:rPr lang="en-US" smtClean="0"/>
-              <a:t>8/6/2026</a:t>
+              <a:t>8/14/2026</a:t>
             </a:fld>
             <a:endParaRPr lang="en-US"/>
           </a:p>
@@ -1279,7 +1280,7 @@
           <a:p>
             <a:fld id="{EB5E7B66-BBF3-4C82-9864-576602C32F66}" type="datetimeFigureOut">
               <a:rPr lang="en-US" smtClean="0"/>
-              <a:t>8/6/2026</a:t>
+              <a:t>8/14/2026</a:t>
             </a:fld>
             <a:endParaRPr lang="en-US"/>
           </a:p>
@@ -1477,7 +1478,7 @@
           <a:p>
             <a:fld id="{EB5E7B66-BBF3-4C82-9864-576602C32F66}" type="datetimeFigureOut">
               <a:rPr lang="en-US" smtClean="0"/>
-              <a:t>8/6/2026</a:t>
+              <a:t>8/14/2026</a:t>
             </a:fld>
             <a:endParaRPr lang="en-US"/>
           </a:p>
@@ -1752,7 +1753,7 @@
           <a:p>
             <a:fld id="{EB5E7B66-BBF3-4C82-9864-576602C32F66}" type="datetimeFigureOut">
               <a:rPr lang="en-US" smtClean="0"/>
-              <a:t>8/6/2026</a:t>
+              <a:t>8/14/2026</a:t>
             </a:fld>
             <a:endParaRPr lang="en-US"/>
           </a:p>
@@ -2017,7 +2018,7 @@
           <a:p>
             <a:fld id="{EB5E7B66-BBF3-4C82-9864-576602C32F66}" type="datetimeFigureOut">
               <a:rPr lang="en-US" smtClean="0"/>
-              <a:t>8/6/2026</a:t>
+              <a:t>8/14/2026</a:t>
             </a:fld>
             <a:endParaRPr lang="en-US"/>
           </a:p>
@@ -2429,7 +2430,7 @@
           <a:p>
             <a:fld id="{EB5E7B66-BBF3-4C82-9864-576602C32F66}" type="datetimeFigureOut">
               <a:rPr lang="en-US" smtClean="0"/>
-              <a:t>8/6/2026</a:t>
+              <a:t>8/14/2026</a:t>
             </a:fld>
             <a:endParaRPr lang="en-US"/>
           </a:p>
@@ -2570,7 +2571,7 @@
           <a:p>
             <a:fld id="{EB5E7B66-BBF3-4C82-9864-576602C32F66}" type="datetimeFigureOut">
               <a:rPr lang="en-US" smtClean="0"/>
-              <a:t>8/6/2026</a:t>
+              <a:t>8/14/2026</a:t>
             </a:fld>
             <a:endParaRPr lang="en-US"/>
           </a:p>
@@ -2683,7 +2684,7 @@
           <a:p>
             <a:fld id="{EB5E7B66-BBF3-4C82-9864-576602C32F66}" type="datetimeFigureOut">
               <a:rPr lang="en-US" smtClean="0"/>
-              <a:t>8/6/2026</a:t>
+              <a:t>8/14/2026</a:t>
             </a:fld>
             <a:endParaRPr lang="en-US"/>
           </a:p>
@@ -2994,7 +2995,7 @@
           <a:p>
             <a:fld id="{EB5E7B66-BBF3-4C82-9864-576602C32F66}" type="datetimeFigureOut">
               <a:rPr lang="en-US" smtClean="0"/>
-              <a:t>8/6/2026</a:t>
+              <a:t>8/14/2026</a:t>
             </a:fld>
             <a:endParaRPr lang="en-US"/>
           </a:p>
@@ -3282,7 +3283,7 @@
           <a:p>
             <a:fld id="{EB5E7B66-BBF3-4C82-9864-576602C32F66}" type="datetimeFigureOut">
               <a:rPr lang="en-US" smtClean="0"/>
-              <a:t>8/6/2026</a:t>
+              <a:t>8/14/2026</a:t>
             </a:fld>
             <a:endParaRPr lang="en-US"/>
           </a:p>
@@ -3523,7 +3524,7 @@
           <a:p>
             <a:fld id="{EB5E7B66-BBF3-4C82-9864-576602C32F66}" type="datetimeFigureOut">
               <a:rPr lang="en-US" smtClean="0"/>
-              <a:t>8/6/2026</a:t>
+              <a:t>8/14/2026</a:t>
             </a:fld>
             <a:endParaRPr lang="en-US"/>
           </a:p>
@@ -4648,6 +4649,127 @@
     <p:extLst>
       <p:ext uri="{BB962C8B-B14F-4D97-AF65-F5344CB8AC3E}">
         <p14:creationId xmlns:p14="http://schemas.microsoft.com/office/powerpoint/2010/main" val="1620516824"/>
+      </p:ext>
+    </p:extLst>
+  </p:cSld>
+  <p:clrMapOvr>
+    <a:masterClrMapping/>
+  </p:clrMapOvr>
+</p:sld>
+</file>
+
+<file path=ppt/slides/slide12.xml><?xml version="1.0" encoding="utf-8"?>
+<p:sld xmlns:a="http://schemas.openxmlformats.org/drawingml/2006/main" xmlns:r="http://schemas.openxmlformats.org/officeDocument/2006/relationships" xmlns:p="http://schemas.openxmlformats.org/presentationml/2006/main">
+  <p:cSld>
+    <p:spTree>
+      <p:nvGrpSpPr>
+        <p:cNvPr id="1" name="">
+          <a:extLst>
+            <a:ext uri="{FF2B5EF4-FFF2-40B4-BE49-F238E27FC236}">
+              <a16:creationId xmlns:a16="http://schemas.microsoft.com/office/drawing/2014/main" id="{DD6D812E-7F7B-49BE-4E83-C439F8D103B9}"/>
+            </a:ext>
+          </a:extLst>
+        </p:cNvPr>
+        <p:cNvGrpSpPr/>
+        <p:nvPr/>
+      </p:nvGrpSpPr>
+      <p:grpSpPr>
+        <a:xfrm>
+          <a:off x="0" y="0"/>
+          <a:ext cx="0" cy="0"/>
+          <a:chOff x="0" y="0"/>
+          <a:chExt cx="0" cy="0"/>
+        </a:xfrm>
+      </p:grpSpPr>
+      <p:sp>
+        <p:nvSpPr>
+          <p:cNvPr id="2" name="Title 1">
+            <a:extLst>
+              <a:ext uri="{FF2B5EF4-FFF2-40B4-BE49-F238E27FC236}">
+                <a16:creationId xmlns:a16="http://schemas.microsoft.com/office/drawing/2014/main" id="{ED4C2822-DD12-3582-EF84-A49CFCCED621}"/>
+              </a:ext>
+            </a:extLst>
+          </p:cNvPr>
+          <p:cNvSpPr>
+            <a:spLocks noGrp="1"/>
+          </p:cNvSpPr>
+          <p:nvPr>
+            <p:ph type="title"/>
+          </p:nvPr>
+        </p:nvSpPr>
+        <p:spPr/>
+        <p:txBody>
+          <a:bodyPr/>
+          <a:lstStyle/>
+          <a:p>
+            <a:endParaRPr lang="en-US"/>
+          </a:p>
+        </p:txBody>
+      </p:sp>
+      <p:sp>
+        <p:nvSpPr>
+          <p:cNvPr id="3" name="Content Placeholder 2">
+            <a:extLst>
+              <a:ext uri="{FF2B5EF4-FFF2-40B4-BE49-F238E27FC236}">
+                <a16:creationId xmlns:a16="http://schemas.microsoft.com/office/drawing/2014/main" id="{758024A5-CFCB-D886-71A3-8D0FBEC5869C}"/>
+              </a:ext>
+            </a:extLst>
+          </p:cNvPr>
+          <p:cNvSpPr>
+            <a:spLocks noGrp="1"/>
+          </p:cNvSpPr>
+          <p:nvPr>
+            <p:ph idx="1"/>
+          </p:nvPr>
+        </p:nvSpPr>
+        <p:spPr/>
+        <p:txBody>
+          <a:bodyPr/>
+          <a:lstStyle/>
+          <a:p>
+            <a:endParaRPr lang="en-US"/>
+          </a:p>
+        </p:txBody>
+      </p:sp>
+      <p:pic>
+        <p:nvPicPr>
+          <p:cNvPr id="4" name="IO_state">
+            <a:extLst>
+              <a:ext uri="{FF2B5EF4-FFF2-40B4-BE49-F238E27FC236}">
+                <a16:creationId xmlns:a16="http://schemas.microsoft.com/office/drawing/2014/main" id="{42FA392C-8929-423C-30D3-2664821BB64F}"/>
+              </a:ext>
+            </a:extLst>
+          </p:cNvPr>
+          <p:cNvPicPr>
+            <a:picLocks noChangeAspect="1"/>
+          </p:cNvPicPr>
+          <p:nvPr/>
+        </p:nvPicPr>
+        <p:blipFill>
+          <a:blip r:embed="rId2">
+            <a:extLst>
+              <a:ext uri="{28A0092B-C50C-407E-A947-70E740481C1C}">
+                <a14:useLocalDpi xmlns:a14="http://schemas.microsoft.com/office/drawing/2010/main" val="0"/>
+              </a:ext>
+            </a:extLst>
+          </a:blip>
+          <a:srcRect/>
+          <a:stretch/>
+        </p:blipFill>
+        <p:spPr>
+          <a:xfrm>
+            <a:off x="892175" y="225460"/>
+            <a:ext cx="10306050" cy="6407079"/>
+          </a:xfrm>
+          <a:prstGeom prst="rect">
+            <a:avLst/>
+          </a:prstGeom>
+        </p:spPr>
+      </p:pic>
+    </p:spTree>
+    <p:extLst>
+      <p:ext uri="{BB962C8B-B14F-4D97-AF65-F5344CB8AC3E}">
+        <p14:creationId xmlns:p14="http://schemas.microsoft.com/office/powerpoint/2010/main" val="822640340"/>
       </p:ext>
     </p:extLst>
   </p:cSld>

</xml_diff>